<commit_message>
gestion des whales out dans tableau hors contexte de protocole ships
</commit_message>
<xml_diff>
--- a/icons/20240723-iconesPNMC.pptx
+++ b/icons/20240723-iconesPNMC.pptx
@@ -10,6 +10,7 @@
     <p:sldId id="259" r:id="rId4"/>
     <p:sldId id="257" r:id="rId5"/>
     <p:sldId id="258" r:id="rId6"/>
+    <p:sldId id="261" r:id="rId7"/>
   </p:sldIdLst>
   <p:sldSz cx="12192000" cy="6858000"/>
   <p:notesSz cx="6858000" cy="9144000"/>
@@ -245,7 +246,7 @@
           <a:p>
             <a:fld id="{D69CC91C-3FCF-491C-901A-4654FCD0FDAC}" type="datetimeFigureOut">
               <a:rPr lang="fr-FR" smtClean="0"/>
-              <a:t>24/06/2026</a:t>
+              <a:t>12/08/2026</a:t>
             </a:fld>
             <a:endParaRPr lang="fr-FR"/>
           </a:p>
@@ -413,7 +414,7 @@
           <a:p>
             <a:fld id="{D69CC91C-3FCF-491C-901A-4654FCD0FDAC}" type="datetimeFigureOut">
               <a:rPr lang="fr-FR" smtClean="0"/>
-              <a:t>24/06/2026</a:t>
+              <a:t>12/08/2026</a:t>
             </a:fld>
             <a:endParaRPr lang="fr-FR"/>
           </a:p>
@@ -591,7 +592,7 @@
           <a:p>
             <a:fld id="{D69CC91C-3FCF-491C-901A-4654FCD0FDAC}" type="datetimeFigureOut">
               <a:rPr lang="fr-FR" smtClean="0"/>
-              <a:t>24/06/2026</a:t>
+              <a:t>12/08/2026</a:t>
             </a:fld>
             <a:endParaRPr lang="fr-FR"/>
           </a:p>
@@ -759,7 +760,7 @@
           <a:p>
             <a:fld id="{D69CC91C-3FCF-491C-901A-4654FCD0FDAC}" type="datetimeFigureOut">
               <a:rPr lang="fr-FR" smtClean="0"/>
-              <a:t>24/06/2026</a:t>
+              <a:t>12/08/2026</a:t>
             </a:fld>
             <a:endParaRPr lang="fr-FR"/>
           </a:p>
@@ -1004,7 +1005,7 @@
           <a:p>
             <a:fld id="{D69CC91C-3FCF-491C-901A-4654FCD0FDAC}" type="datetimeFigureOut">
               <a:rPr lang="fr-FR" smtClean="0"/>
-              <a:t>24/06/2026</a:t>
+              <a:t>12/08/2026</a:t>
             </a:fld>
             <a:endParaRPr lang="fr-FR"/>
           </a:p>
@@ -1233,7 +1234,7 @@
           <a:p>
             <a:fld id="{D69CC91C-3FCF-491C-901A-4654FCD0FDAC}" type="datetimeFigureOut">
               <a:rPr lang="fr-FR" smtClean="0"/>
-              <a:t>24/06/2026</a:t>
+              <a:t>12/08/2026</a:t>
             </a:fld>
             <a:endParaRPr lang="fr-FR"/>
           </a:p>
@@ -1597,7 +1598,7 @@
           <a:p>
             <a:fld id="{D69CC91C-3FCF-491C-901A-4654FCD0FDAC}" type="datetimeFigureOut">
               <a:rPr lang="fr-FR" smtClean="0"/>
-              <a:t>24/06/2026</a:t>
+              <a:t>12/08/2026</a:t>
             </a:fld>
             <a:endParaRPr lang="fr-FR"/>
           </a:p>
@@ -1714,7 +1715,7 @@
           <a:p>
             <a:fld id="{D69CC91C-3FCF-491C-901A-4654FCD0FDAC}" type="datetimeFigureOut">
               <a:rPr lang="fr-FR" smtClean="0"/>
-              <a:t>24/06/2026</a:t>
+              <a:t>12/08/2026</a:t>
             </a:fld>
             <a:endParaRPr lang="fr-FR"/>
           </a:p>
@@ -1809,7 +1810,7 @@
           <a:p>
             <a:fld id="{D69CC91C-3FCF-491C-901A-4654FCD0FDAC}" type="datetimeFigureOut">
               <a:rPr lang="fr-FR" smtClean="0"/>
-              <a:t>24/06/2026</a:t>
+              <a:t>12/08/2026</a:t>
             </a:fld>
             <a:endParaRPr lang="fr-FR"/>
           </a:p>
@@ -2084,7 +2085,7 @@
           <a:p>
             <a:fld id="{D69CC91C-3FCF-491C-901A-4654FCD0FDAC}" type="datetimeFigureOut">
               <a:rPr lang="fr-FR" smtClean="0"/>
-              <a:t>24/06/2026</a:t>
+              <a:t>12/08/2026</a:t>
             </a:fld>
             <a:endParaRPr lang="fr-FR"/>
           </a:p>
@@ -2336,7 +2337,7 @@
           <a:p>
             <a:fld id="{D69CC91C-3FCF-491C-901A-4654FCD0FDAC}" type="datetimeFigureOut">
               <a:rPr lang="fr-FR" smtClean="0"/>
-              <a:t>24/06/2026</a:t>
+              <a:t>12/08/2026</a:t>
             </a:fld>
             <a:endParaRPr lang="fr-FR"/>
           </a:p>
@@ -2547,7 +2548,7 @@
           <a:p>
             <a:fld id="{D69CC91C-3FCF-491C-901A-4654FCD0FDAC}" type="datetimeFigureOut">
               <a:rPr lang="fr-FR" smtClean="0"/>
-              <a:t>24/06/2026</a:t>
+              <a:t>12/08/2026</a:t>
             </a:fld>
             <a:endParaRPr lang="fr-FR"/>
           </a:p>
@@ -5149,10 +5150,160 @@
           </a:p>
         </p:txBody>
       </p:sp>
+      <p:pic>
+        <p:nvPicPr>
+          <p:cNvPr id="3" name="Image 2">
+            <a:extLst>
+              <a:ext uri="{FF2B5EF4-FFF2-40B4-BE49-F238E27FC236}">
+                <a16:creationId xmlns:a16="http://schemas.microsoft.com/office/drawing/2014/main" id="{69FBF3C8-BD90-4039-AF4C-B21CAC2CCED5}"/>
+              </a:ext>
+            </a:extLst>
+          </p:cNvPr>
+          <p:cNvPicPr>
+            <a:picLocks noChangeAspect="1"/>
+          </p:cNvPicPr>
+          <p:nvPr/>
+        </p:nvPicPr>
+        <p:blipFill>
+          <a:blip r:embed="rId2">
+            <a:extLst>
+              <a:ext uri="{28A0092B-C50C-407E-A947-70E740481C1C}">
+                <a14:useLocalDpi xmlns:a14="http://schemas.microsoft.com/office/drawing/2010/main" val="0"/>
+              </a:ext>
+            </a:extLst>
+          </a:blip>
+          <a:stretch>
+            <a:fillRect/>
+          </a:stretch>
+        </p:blipFill>
+        <p:spPr>
+          <a:xfrm>
+            <a:off x="8316813" y="3001751"/>
+            <a:ext cx="742950" cy="742950"/>
+          </a:xfrm>
+          <a:prstGeom prst="rect">
+            <a:avLst/>
+          </a:prstGeom>
+        </p:spPr>
+      </p:pic>
+      <p:sp>
+        <p:nvSpPr>
+          <p:cNvPr id="25" name="Flèche droite 11">
+            <a:extLst>
+              <a:ext uri="{FF2B5EF4-FFF2-40B4-BE49-F238E27FC236}">
+                <a16:creationId xmlns:a16="http://schemas.microsoft.com/office/drawing/2014/main" id="{B726D91B-2530-45DD-8A96-3736A469E422}"/>
+              </a:ext>
+            </a:extLst>
+          </p:cNvPr>
+          <p:cNvSpPr/>
+          <p:nvPr/>
+        </p:nvSpPr>
+        <p:spPr>
+          <a:xfrm rot="16200000">
+            <a:off x="3545654" y="1841501"/>
+            <a:ext cx="165323" cy="165323"/>
+          </a:xfrm>
+          <a:prstGeom prst="flowChartSummingJunction">
+            <a:avLst/>
+          </a:prstGeom>
+          <a:solidFill>
+            <a:schemeClr val="bg1"/>
+          </a:solidFill>
+          <a:ln w="12700">
+            <a:solidFill>
+              <a:schemeClr val="tx1"/>
+            </a:solidFill>
+          </a:ln>
+        </p:spPr>
+        <p:style>
+          <a:lnRef idx="2">
+            <a:schemeClr val="accent1">
+              <a:shade val="50000"/>
+            </a:schemeClr>
+          </a:lnRef>
+          <a:fillRef idx="1">
+            <a:schemeClr val="accent1"/>
+          </a:fillRef>
+          <a:effectRef idx="0">
+            <a:schemeClr val="accent1"/>
+          </a:effectRef>
+          <a:fontRef idx="minor">
+            <a:schemeClr val="lt1"/>
+          </a:fontRef>
+        </p:style>
+        <p:txBody>
+          <a:bodyPr rtlCol="0" anchor="ctr"/>
+          <a:lstStyle/>
+          <a:p>
+            <a:pPr algn="ctr"/>
+            <a:endParaRPr lang="fr-FR" sz="1600"/>
+          </a:p>
+        </p:txBody>
+      </p:sp>
     </p:spTree>
     <p:extLst>
       <p:ext uri="{BB962C8B-B14F-4D97-AF65-F5344CB8AC3E}">
         <p14:creationId xmlns:p14="http://schemas.microsoft.com/office/powerpoint/2010/main" val="1049974151"/>
+      </p:ext>
+    </p:extLst>
+  </p:cSld>
+  <p:clrMapOvr>
+    <a:masterClrMapping/>
+  </p:clrMapOvr>
+</p:sld>
+</file>
+
+<file path=ppt/slides/slide6.xml><?xml version="1.0" encoding="utf-8"?>
+<p:sld xmlns:a="http://schemas.openxmlformats.org/drawingml/2006/main" xmlns:r="http://schemas.openxmlformats.org/officeDocument/2006/relationships" xmlns:p="http://schemas.openxmlformats.org/presentationml/2006/main">
+  <p:cSld>
+    <p:spTree>
+      <p:nvGrpSpPr>
+        <p:cNvPr id="1" name=""/>
+        <p:cNvGrpSpPr/>
+        <p:nvPr/>
+      </p:nvGrpSpPr>
+      <p:grpSpPr>
+        <a:xfrm>
+          <a:off x="0" y="0"/>
+          <a:ext cx="0" cy="0"/>
+          <a:chOff x="0" y="0"/>
+          <a:chExt cx="0" cy="0"/>
+        </a:xfrm>
+      </p:grpSpPr>
+      <p:pic>
+        <p:nvPicPr>
+          <p:cNvPr id="3" name="Image 2">
+            <a:extLst>
+              <a:ext uri="{FF2B5EF4-FFF2-40B4-BE49-F238E27FC236}">
+                <a16:creationId xmlns:a16="http://schemas.microsoft.com/office/drawing/2014/main" id="{0E9C2CB5-D59E-4A04-8BF4-E3DA6A7836E2}"/>
+              </a:ext>
+            </a:extLst>
+          </p:cNvPr>
+          <p:cNvPicPr>
+            <a:picLocks noChangeAspect="1"/>
+          </p:cNvPicPr>
+          <p:nvPr/>
+        </p:nvPicPr>
+        <p:blipFill>
+          <a:blip r:embed="rId2"/>
+          <a:stretch>
+            <a:fillRect/>
+          </a:stretch>
+        </p:blipFill>
+        <p:spPr>
+          <a:xfrm>
+            <a:off x="1493368" y="0"/>
+            <a:ext cx="9205264" cy="6858000"/>
+          </a:xfrm>
+          <a:prstGeom prst="rect">
+            <a:avLst/>
+          </a:prstGeom>
+        </p:spPr>
+      </p:pic>
+    </p:spTree>
+    <p:extLst>
+      <p:ext uri="{BB962C8B-B14F-4D97-AF65-F5344CB8AC3E}">
+        <p14:creationId xmlns:p14="http://schemas.microsoft.com/office/powerpoint/2010/main" val="364000511"/>
       </p:ext>
     </p:extLst>
   </p:cSld>

</xml_diff>